<commit_message>
Update RC1 architecture and compact development documentation
</commit_message>
<xml_diff>
--- a/docs/architecture-slide.pptx
+++ b/docs/architecture-slide.pptx
@@ -2,13 +2,13 @@
 <file path=ppt/presentation.xml><?xml version="1.0" encoding="utf-8"?>
 <p:presentation xmlns:p="http://schemas.openxmlformats.org/presentationml/2006/main">
   <p:sldMasterIdLst>
-    <p:sldMasterId xmlns:r="http://schemas.openxmlformats.org/officeDocument/2006/relationships" id="2147483648" r:id="Rfad600f826144803"/>
+    <p:sldMasterId xmlns:r="http://schemas.openxmlformats.org/officeDocument/2006/relationships" id="2147483648" r:id="R29d4763999814d03"/>
   </p:sldMasterIdLst>
   <p:notesMasterIdLst>
-    <p:notesMasterId xmlns:r="http://schemas.openxmlformats.org/officeDocument/2006/relationships" r:id="R968ec1beca9d47d3"/>
+    <p:notesMasterId xmlns:r="http://schemas.openxmlformats.org/officeDocument/2006/relationships" r:id="R88eb56ca2f1d4e10"/>
   </p:notesMasterIdLst>
   <p:sldIdLst>
-    <p:sldId xmlns:r="http://schemas.openxmlformats.org/officeDocument/2006/relationships" id="256" r:id="R62f35e61bbd84d4d"/>
+    <p:sldId xmlns:r="http://schemas.openxmlformats.org/officeDocument/2006/relationships" id="256" r:id="Re04adfaae5df46c1"/>
   </p:sldIdLst>
   <p:sldSz cx="12192000" cy="6858000"/>
   <p:notesSz cx="6858000" cy="9144000"/>
@@ -586,32 +586,32 @@
           <a:lstStyle xmlns:a="http://schemas.openxmlformats.org/drawingml/2006/main"/>
           <a:p xmlns:a="http://schemas.openxmlformats.org/drawingml/2006/main">
             <a:r>
-              <a:t>2026-10-21 R02。現行実装: Windowsホスト0.5.0-preview.1 + gemini-hotspot-trust-20261021-r01。基点97f2e48。</a:t>
-            </a:r>
-          </a:p>
-          <a:p xmlns:a="http://schemas.openxmlformats.org/drawingml/2006/main">
-            <a:r>
-              <a:t>端末: M5 AtomS3R + Atomic Voice Base A149。Arduino-ESP32 2.0.17、PlatformIO Espressif32 6.11.0。ローカルのMFCC/DTW照合・3回登録。16 kHz/16-bit/mono入力、24 kHz回答。録音と再生は半二重。準備完了→ビープ→終了から0.7秒で発話。</a:t>
-            </a:r>
-          </a:p>
-          <a:p xmlns:a="http://schemas.openxmlformats.org/drawingml/2006/main">
-            <a:r>
-              <a:t>端末はDHCPゲートウェイへ自動接続。Windowsは稼働中のWi-Fi Direct側IPv4/サブネットを検出し、TCP48443へバインド、HTTP/WS接続元をサブネットで限定する。IPアドレスは固定しない。通常経路にはアプリ独自TLS/Bearer/端末コードを使わず、無線区間の保護と参加認証をWi-Fi暗号化・パスワードに委ねる。同じホットスポットへ参加できる機器も利用可能になる。</a:t>
-            </a:r>
-          </a:p>
-          <a:p xmlns:a="http://schemas.openxmlformats.org/drawingml/2006/main">
-            <a:r>
-              <a:t>Gemini APIキーはPCのみ。DPAPI保存は任意。登録音声・呼びかけはクラウドへ送らない。質問音声をGemini Liveへ送る。旧USB診断経路・汎用サーバーの旧TLS対応は残るが、この図の通常経路では使用しない。</a:t>
-            </a:r>
-          </a:p>
-          <a:p xmlns:a="http://schemas.openxmlformats.org/drawingml/2006/main">
-            <a:r>
-              <a:t>利用者確認: コードなし接続、3回登録Call saved、呼びかけ→回答音声・口パク→待受復帰、端末リセット後の自動再接続と再会話。端末測定: MATCH距離188/187、質問PASS/played=1、受付700/701ms。端末リセット試験を電源断試験とは扱わない。長期精度、電源断、別PC、Piは未検証。</a:t>
-            </a:r>
-          </a:p>
-          <a:p xmlns:a="http://schemas.openxmlformats.org/drawingml/2006/main">
-            <a:r>
-              <a:t>一次資料（案件内）: docs/HOTSPOT_TRUST.md、src/LocalGemini.cpp、include/WirelessLink.h、desktop/wireless.py、desktop/host_app.py、server/gemini-server.ts、docs/WAKE_STAGE3_R07.md。経緯と残作業: docs/RESUME.md。Piは将来候補で今回実装なし。</a:t>
+              <a:t>2026-10-21 R03。現行候補はWindowsホスト0.6.0-rc.1とAtomS3R無線端末RC1。端末はAtomic Voice Base A149、PlatformIO espressif32 6.11.0 / Arduino-ESP32 2.0.17。通常USB制御・監視なし。上段はモードのみ、診断数値と音量バーは削除。3回の呼びかけ登録は端末内MFCC/DTW、準備・ビープ終了700ms後の発話受付、半二重、1質問1回答。回答はスピーカー有効化後200ms待って元PCM全体を再生する。</a:t>
+            </a:r>
+          </a:p>
+          <a:p xmlns:a="http://schemas.openxmlformats.org/drawingml/2006/main">
+            <a:r>
+              <a:t>ホストはWi-Fi固定、USB選択UIは廃止。PCでサンプルを最後まで聴き採用すると、通常の声プルダウンに即時追加・選択・保存する。PC試聴時は利用者が端末をSleepingにする。速度とピッチ調整なし。キーはホストだけで使用し、任意DPAPI保存。端末にAPIキーを渡さない。</a:t>
+            </a:r>
+          </a:p>
+          <a:p xmlns:a="http://schemas.openxmlformats.org/drawingml/2006/main">
+            <a:r>
+              <a:t>端末はDHCPゲートウェイTCP48443へ自動接続。ホストはホットスポット側IPv4に限定して待受し、同じサブネットの接続元だけを受付。通常経路はHTTP/WS、保護と参加確認はホットスポットのWi-Fi暗号化・パスワード。同じホットスポット参加機器も受付対象。クラウドへはWSS。</a:t>
+            </a:r>
+          </a:p>
+          <a:p xmlns:a="http://schemas.openxmlformats.org/drawingml/2006/main">
+            <a:r>
+              <a:t>利用者が直前の200ms待機版で冒頭欠け無しと報告。RC1の表示・会話・待受確認依頼へokと回答。以前のリセット後約5秒再接続と会話も基本確認済み。これらを長期精度・誤検出率・電源断耐性・別PCでの試験合格とは扱わない。</a:t>
+            </a:r>
+          </a:p>
+          <a:p xmlns:a="http://schemas.openxmlformats.org/drawingml/2006/main">
+            <a:r>
+              <a:t>将来ToDo: Raspberry Pi OSホスト、macOSホスト、ホスト無しでESP32-S3からGeminiへ直接対話する別構成。いずれも未着手。直接構成では認証/キー保護、TLS/WSS、メモリ、再接続、遅延を設計評価する。現行のPC中継や旧OpenAI併用単体版と区別する。</a:t>
+            </a:r>
+          </a:p>
+          <a:p xmlns:a="http://schemas.openxmlformats.org/drawingml/2006/main">
+            <a:r>
+              <a:t>一次資料（案件内）: README.md、TODO.md、docs/RESUME.md、docs/HOTSPOT_TRUST.md、docs/RELEASE_CANDIDATE_0_6_0_2026-10-21.md、docs/REPLY_START_DELAY_2026-10-21.md、desktop/README.ja.md、src/LocalGemini.cpp、src/FaceUI.cpp、desktop/host_app.py。</a:t>
             </a:r>
           </a:p>
         </p:txBody>
@@ -3636,17 +3636,17 @@
   </p:cSld>
   <p:clrMap bg1="lt1" tx1="dk1" bg2="lt2" tx2="dk2" accent1="accent1" accent2="accent2" accent3="accent3" accent4="accent4" accent5="accent5" accent6="accent6" hlink="hlink" folHlink="folHlink"/>
   <p:sldLayoutIdLst>
-    <p:sldLayoutId xmlns:r="http://schemas.openxmlformats.org/officeDocument/2006/relationships" id="2147483649" r:id="Rdc3f36905f50427b"/>
-    <p:sldLayoutId xmlns:r="http://schemas.openxmlformats.org/officeDocument/2006/relationships" id="2147483650" r:id="Rf4bf0f42841a4980"/>
-    <p:sldLayoutId xmlns:r="http://schemas.openxmlformats.org/officeDocument/2006/relationships" id="2147483651" r:id="Rd99c906671664e9d"/>
-    <p:sldLayoutId xmlns:r="http://schemas.openxmlformats.org/officeDocument/2006/relationships" id="2147483652" r:id="R0fdb185c17904bbe"/>
-    <p:sldLayoutId xmlns:r="http://schemas.openxmlformats.org/officeDocument/2006/relationships" id="2147483653" r:id="R9a16c629d47b421d"/>
-    <p:sldLayoutId xmlns:r="http://schemas.openxmlformats.org/officeDocument/2006/relationships" id="2147483654" r:id="Reb8aa25b3a7e465c"/>
-    <p:sldLayoutId xmlns:r="http://schemas.openxmlformats.org/officeDocument/2006/relationships" id="2147483655" r:id="R95db3d96d7ac447a"/>
-    <p:sldLayoutId xmlns:r="http://schemas.openxmlformats.org/officeDocument/2006/relationships" id="2147483656" r:id="R39509ea0bc0c4080"/>
-    <p:sldLayoutId xmlns:r="http://schemas.openxmlformats.org/officeDocument/2006/relationships" id="2147483657" r:id="R4ad7ba4f4b324ccc"/>
-    <p:sldLayoutId xmlns:r="http://schemas.openxmlformats.org/officeDocument/2006/relationships" id="2147483658" r:id="Ra19279933b8e4489"/>
-    <p:sldLayoutId xmlns:r="http://schemas.openxmlformats.org/officeDocument/2006/relationships" id="2147483659" r:id="R2ef60813e9604e34"/>
+    <p:sldLayoutId xmlns:r="http://schemas.openxmlformats.org/officeDocument/2006/relationships" id="2147483649" r:id="R6bba7d1a05cf4abc"/>
+    <p:sldLayoutId xmlns:r="http://schemas.openxmlformats.org/officeDocument/2006/relationships" id="2147483650" r:id="R0df9f64171f34270"/>
+    <p:sldLayoutId xmlns:r="http://schemas.openxmlformats.org/officeDocument/2006/relationships" id="2147483651" r:id="Re6e3f811928d4b2b"/>
+    <p:sldLayoutId xmlns:r="http://schemas.openxmlformats.org/officeDocument/2006/relationships" id="2147483652" r:id="R107ae45e9c3a49a3"/>
+    <p:sldLayoutId xmlns:r="http://schemas.openxmlformats.org/officeDocument/2006/relationships" id="2147483653" r:id="R8761479f1f444451"/>
+    <p:sldLayoutId xmlns:r="http://schemas.openxmlformats.org/officeDocument/2006/relationships" id="2147483654" r:id="R93c975f44a684eab"/>
+    <p:sldLayoutId xmlns:r="http://schemas.openxmlformats.org/officeDocument/2006/relationships" id="2147483655" r:id="Rc5c8b6aa71a94a26"/>
+    <p:sldLayoutId xmlns:r="http://schemas.openxmlformats.org/officeDocument/2006/relationships" id="2147483656" r:id="R799213779e294603"/>
+    <p:sldLayoutId xmlns:r="http://schemas.openxmlformats.org/officeDocument/2006/relationships" id="2147483657" r:id="Rb3235a9a1faf4f04"/>
+    <p:sldLayoutId xmlns:r="http://schemas.openxmlformats.org/officeDocument/2006/relationships" id="2147483658" r:id="R25aa7a74e5af4588"/>
+    <p:sldLayoutId xmlns:r="http://schemas.openxmlformats.org/officeDocument/2006/relationships" id="2147483659" r:id="Raea7805aea8c4859"/>
   </p:sldLayoutIdLst>
   <p:txStyles>
     <p:titleStyle>
@@ -4364,7 +4364,7 @@
         <p:spPr>
           <a:xfrm xmlns:a="http://schemas.openxmlformats.org/drawingml/2006/main">
             <a:off x="457200" y="668045"/>
-            <a:ext cx="6811963" cy="173736"/>
+            <a:ext cx="6065838" cy="173736"/>
           </a:xfrm>
           <a:prstGeom xmlns:a="http://schemas.openxmlformats.org/drawingml/2006/main" prst="rect">
             <a:avLst/>
@@ -4386,7 +4386,7 @@
                 <a:ea typeface="Yu Gothic"/>
                 <a:cs typeface="Yu Gothic"/>
               </a:rPr>
-              <a:t>Windowsホスト 0.5.0-preview.1 / コード入力不要　　2026.10.21　　● 基本確認済み　◇ 今後・未検証</a:t>
+              <a:t>Windowsホスト 0.6.0-rc.1 / Wi-Fi専用　　2026.10.21　　● 基本確認済み　◇ 将来・未検証</a:t>
             </a:r>
           </a:p>
         </p:txBody>
@@ -5042,7 +5042,7 @@
         <p:spPr>
           <a:xfrm xmlns:a="http://schemas.openxmlformats.org/drawingml/2006/main">
             <a:off x="792480" y="2344445"/>
-            <a:ext cx="2298706" cy="175433"/>
+            <a:ext cx="2174875" cy="173736"/>
           </a:xfrm>
           <a:prstGeom xmlns:a="http://schemas.openxmlformats.org/drawingml/2006/main" prst="rect">
             <a:avLst/>
@@ -5064,62 +5064,7 @@
                 <a:ea typeface="Yu Gothic"/>
                 <a:cs typeface="Yu Gothic"/>
               </a:rPr>
-              <a:t>Sleep / </a:t>
-            </a:r>
-            <a:r>
-              <a:rPr sz="1140">
-                <a:solidFill>
-                  <a:srgbClr val="182B43"/>
-                </a:solidFill>
-                <a:latin typeface="Yu Gothic"/>
-                <a:ea typeface="Yu Gothic"/>
-                <a:cs typeface="Yu Gothic"/>
-              </a:rPr>
-              <a:t>待受 </a:t>
-            </a:r>
-            <a:r>
-              <a:rPr sz="1140">
-                <a:solidFill>
-                  <a:srgbClr val="182B43"/>
-                </a:solidFill>
-                <a:latin typeface="Yu Gothic"/>
-                <a:ea typeface="Yu Gothic"/>
-                <a:cs typeface="Yu Gothic"/>
-              </a:rPr>
-              <a:t>/ </a:t>
-            </a:r>
-            <a:r>
-              <a:rPr sz="1140">
-                <a:solidFill>
-                  <a:srgbClr val="182B43"/>
-                </a:solidFill>
-                <a:latin typeface="Yu Gothic"/>
-                <a:ea typeface="Yu Gothic"/>
-                <a:cs typeface="Yu Gothic"/>
-              </a:rPr>
-              <a:t>録音 </a:t>
-            </a:r>
-            <a:r>
-              <a:rPr sz="1140">
-                <a:solidFill>
-                  <a:srgbClr val="182B43"/>
-                </a:solidFill>
-                <a:latin typeface="Yu Gothic"/>
-                <a:ea typeface="Yu Gothic"/>
-                <a:cs typeface="Yu Gothic"/>
-              </a:rPr>
-              <a:t>/ </a:t>
-            </a:r>
-            <a:r>
-              <a:rPr sz="1140">
-                <a:solidFill>
-                  <a:srgbClr val="182B43"/>
-                </a:solidFill>
-                <a:latin typeface="Yu Gothic"/>
-                <a:ea typeface="Yu Gothic"/>
-                <a:cs typeface="Yu Gothic"/>
-              </a:rPr>
-              <a:t>再生・口パク</a:t>
+              <a:t>上段はモードのみ / 診断表示なし</a:t>
             </a:r>
           </a:p>
         </p:txBody>
@@ -5369,7 +5314,7 @@
         <p:spPr>
           <a:xfrm xmlns:a="http://schemas.openxmlformats.org/drawingml/2006/main">
             <a:off x="792480" y="3769385"/>
-            <a:ext cx="1946046" cy="175433"/>
+            <a:ext cx="2552700" cy="173736"/>
           </a:xfrm>
           <a:prstGeom xmlns:a="http://schemas.openxmlformats.org/drawingml/2006/main" prst="rect">
             <a:avLst/>
@@ -5391,40 +5336,7 @@
                 <a:ea typeface="Yu Gothic"/>
                 <a:cs typeface="Yu Gothic"/>
               </a:rPr>
-              <a:t>16 kHz</a:t>
-            </a:r>
-            <a:r>
-              <a:rPr sz="1140">
-                <a:solidFill>
-                  <a:srgbClr val="182B43"/>
-                </a:solidFill>
-                <a:latin typeface="Yu Gothic"/>
-                <a:ea typeface="Yu Gothic"/>
-                <a:cs typeface="Yu Gothic"/>
-              </a:rPr>
-              <a:t>入力 </a:t>
-            </a:r>
-            <a:r>
-              <a:rPr sz="1140">
-                <a:solidFill>
-                  <a:srgbClr val="182B43"/>
-                </a:solidFill>
-                <a:latin typeface="Yu Gothic"/>
-                <a:ea typeface="Yu Gothic"/>
-                <a:cs typeface="Yu Gothic"/>
-              </a:rPr>
-              <a:t>/ 24 kHz</a:t>
-            </a:r>
-            <a:r>
-              <a:rPr sz="1140">
-                <a:solidFill>
-                  <a:srgbClr val="182B43"/>
-                </a:solidFill>
-                <a:latin typeface="Yu Gothic"/>
-                <a:ea typeface="Yu Gothic"/>
-                <a:cs typeface="Yu Gothic"/>
-              </a:rPr>
-              <a:t>回答再生</a:t>
+              <a:t>16 kHz入力 / 24 kHz回答・前置200 ms</a:t>
             </a:r>
           </a:p>
         </p:txBody>
@@ -5872,7 +5784,7 @@
         <p:spPr>
           <a:xfrm xmlns:a="http://schemas.openxmlformats.org/drawingml/2006/main">
             <a:off x="4511040" y="2899105"/>
-            <a:ext cx="2235200" cy="201168"/>
+            <a:ext cx="2282825" cy="201168"/>
           </a:xfrm>
           <a:prstGeom xmlns:a="http://schemas.openxmlformats.org/drawingml/2006/main" prst="rect">
             <a:avLst/>
@@ -5894,7 +5806,7 @@
                 <a:ea typeface="Yu Gothic"/>
                 <a:cs typeface="Yu Gothic"/>
               </a:rPr>
-              <a:t>● ホットスポット接続の信頼</a:t>
+              <a:t>● 声の選択・PCサンプル試聴</a:t>
             </a:r>
           </a:p>
         </p:txBody>
@@ -5916,7 +5828,7 @@
         <p:spPr>
           <a:xfrm xmlns:a="http://schemas.openxmlformats.org/drawingml/2006/main">
             <a:off x="4663440" y="3167405"/>
-            <a:ext cx="2155825" cy="173736"/>
+            <a:ext cx="2071688" cy="173736"/>
           </a:xfrm>
           <a:prstGeom xmlns:a="http://schemas.openxmlformats.org/drawingml/2006/main" prst="rect">
             <a:avLst/>
@@ -5938,7 +5850,7 @@
                 <a:ea typeface="Yu Gothic"/>
                 <a:cs typeface="Yu Gothic"/>
               </a:rPr>
-              <a:t>参加済み端末をサブネットで限定</a:t>
+              <a:t>PC試聴後に採用・即時一覧反映</a:t>
             </a:r>
           </a:p>
         </p:txBody>
@@ -5960,7 +5872,7 @@
         <p:spPr>
           <a:xfrm xmlns:a="http://schemas.openxmlformats.org/drawingml/2006/main">
             <a:off x="4663440" y="3388385"/>
-            <a:ext cx="2016125" cy="173736"/>
+            <a:ext cx="1589087" cy="173736"/>
           </a:xfrm>
           <a:prstGeom xmlns:a="http://schemas.openxmlformats.org/drawingml/2006/main" prst="rect">
             <a:avLst/>
@@ -5982,7 +5894,7 @@
                 <a:ea typeface="Yu Gothic"/>
                 <a:cs typeface="Yu Gothic"/>
               </a:rPr>
-              <a:t>ホットスポット側IPだけで待受</a:t>
+              <a:t>採用声と接続設定を保存</a:t>
             </a:r>
           </a:p>
         </p:txBody>
@@ -6240,7 +6152,7 @@
         <p:spPr>
           <a:xfrm xmlns:a="http://schemas.openxmlformats.org/drawingml/2006/main">
             <a:off x="4511040" y="4806772"/>
-            <a:ext cx="2733675" cy="155448"/>
+            <a:ext cx="2212975" cy="155448"/>
           </a:xfrm>
           <a:prstGeom xmlns:a="http://schemas.openxmlformats.org/drawingml/2006/main" prst="rect">
             <a:avLst/>
@@ -6262,7 +6174,7 @@
                 <a:ea typeface="Yu Gothic"/>
                 <a:cs typeface="Yu Gothic"/>
               </a:rPr>
-              <a:t>呼びかけ・音声・口パク・リセット復帰を確認</a:t>
+              <a:t>基本会話・冒頭欠け解消を利用者確認</a:t>
             </a:r>
           </a:p>
         </p:txBody>
@@ -6827,7 +6739,7 @@
         <p:spPr>
           <a:xfrm xmlns:a="http://schemas.openxmlformats.org/drawingml/2006/main">
             <a:off x="8382000" y="4484065"/>
-            <a:ext cx="1758950" cy="201168"/>
+            <a:ext cx="1057275" cy="201168"/>
           </a:xfrm>
           <a:prstGeom xmlns:a="http://schemas.openxmlformats.org/drawingml/2006/main" prst="rect">
             <a:avLst/>
@@ -6849,7 +6761,7 @@
                 <a:ea typeface="Yu Gothic"/>
                 <a:cs typeface="Yu Gothic"/>
               </a:rPr>
-              <a:t>◇ Raspberry Piホスト</a:t>
+              <a:t>◇ 将来の構成</a:t>
             </a:r>
           </a:p>
         </p:txBody>
@@ -6871,7 +6783,7 @@
         <p:spPr>
           <a:xfrm xmlns:a="http://schemas.openxmlformats.org/drawingml/2006/main">
             <a:off x="8534400" y="4752365"/>
-            <a:ext cx="2074863" cy="173736"/>
+            <a:ext cx="2365375" cy="173736"/>
           </a:xfrm>
           <a:prstGeom xmlns:a="http://schemas.openxmlformats.org/drawingml/2006/main" prst="rect">
             <a:avLst/>
@@ -6893,7 +6805,7 @@
                 <a:ea typeface="Yu Gothic"/>
                 <a:cs typeface="Yu Gothic"/>
               </a:rPr>
-              <a:t>将来候補 / AP・常駐化は未実装</a:t>
+              <a:t>RasPi OS / macOS / ESP32-S3直結</a:t>
             </a:r>
           </a:p>
         </p:txBody>
@@ -7338,7 +7250,7 @@
         <p:spPr>
           <a:xfrm xmlns:a="http://schemas.openxmlformats.org/drawingml/2006/main">
             <a:off x="457200" y="6376492"/>
-            <a:ext cx="5126037" cy="155448"/>
+            <a:ext cx="5195888" cy="155448"/>
           </a:xfrm>
           <a:prstGeom xmlns:a="http://schemas.openxmlformats.org/drawingml/2006/main" prst="rect">
             <a:avLst/>
@@ -7360,7 +7272,7 @@
                 <a:ea typeface="Yu Gothic"/>
                 <a:cs typeface="Yu Gothic"/>
               </a:rPr>
-              <a:t>残課題：長期精度・電源断耐性・別PC試験・連続ストリーミング / クラウド公開は保留</a:t>
+              <a:t>残課題：長期精度・電源断・別PC　　将来：他OSホスト・ホスト不要のGemini直接接続</a:t>
             </a:r>
           </a:p>
         </p:txBody>
@@ -7382,7 +7294,7 @@
         <p:spPr>
           <a:xfrm xmlns:a="http://schemas.openxmlformats.org/drawingml/2006/main">
             <a:off x="457200" y="6606692"/>
-            <a:ext cx="5029200" cy="128016"/>
+            <a:ext cx="4343400" cy="128016"/>
           </a:xfrm>
           <a:prstGeom xmlns:a="http://schemas.openxmlformats.org/drawingml/2006/main" prst="rect">
             <a:avLst/>
@@ -7404,7 +7316,7 @@
                 <a:ea typeface="Yu Gothic"/>
                 <a:cs typeface="Yu Gothic"/>
               </a:rPr>
-              <a:t>現行資料：RESUME / HOTSPOT_TRUST / desktop README.ja　※USB診断・従来の端末単体版は省略</a:t>
+              <a:t>現行資料：README / RESUME / TODO / desktop README.ja　　詳細履歴は保管資料へ</a:t>
             </a:r>
           </a:p>
         </p:txBody>

</xml_diff>